<commit_message>
update binary files and slides for LunarLander project
</commit_message>
<xml_diff>
--- a/Homework_4_Slides_Template.pptx
+++ b/Homework_4_Slides_Template.pptx
@@ -28,7 +28,7 @@
       <p:boldItalic r:id="rId14"/>
     </p:embeddedFont>
     <p:embeddedFont>
-      <p:font typeface="PT Sans Narrow" panose="020B0506020203020204" pitchFamily="34" charset="0"/>
+      <p:font typeface="PT Sans Narrow" panose="020B0506020203020204" pitchFamily="34" charset="77"/>
       <p:regular r:id="rId15"/>
       <p:bold r:id="rId16"/>
     </p:embeddedFont>
@@ -1654,7 +1654,7 @@
               </a:spcAft>
               <a:buNone/>
             </a:pPr>
-            <a:endParaRPr/>
+            <a:endParaRPr dirty="0"/>
           </a:p>
         </p:txBody>
       </p:sp>
@@ -8165,8 +8165,8 @@
           </a:prstGeom>
         </p:spPr>
       </p:pic>
-      <mc:AlternateContent xmlns:mc="http://schemas.openxmlformats.org/markup-compatibility/2006">
-        <mc:Choice xmlns:p14="http://schemas.microsoft.com/office/powerpoint/2010/main" Requires="p14">
+      <mc:AlternateContent xmlns:mc="http://schemas.openxmlformats.org/markup-compatibility/2006" xmlns:p14="http://schemas.microsoft.com/office/powerpoint/2010/main">
+        <mc:Choice Requires="p14">
           <p:contentPart p14:bwMode="auto" r:id="rId4">
             <p14:nvContentPartPr>
               <p14:cNvPr id="4" name="Ink 3">
@@ -8185,7 +8185,7 @@
             </p14:xfrm>
           </p:contentPart>
         </mc:Choice>
-        <mc:Fallback>
+        <mc:Fallback xmlns="">
           <p:pic>
             <p:nvPicPr>
               <p:cNvPr id="4" name="Ink 3">
@@ -8216,8 +8216,8 @@
           </p:pic>
         </mc:Fallback>
       </mc:AlternateContent>
-      <mc:AlternateContent xmlns:mc="http://schemas.openxmlformats.org/markup-compatibility/2006">
-        <mc:Choice xmlns:p14="http://schemas.microsoft.com/office/powerpoint/2010/main" Requires="p14">
+      <mc:AlternateContent xmlns:mc="http://schemas.openxmlformats.org/markup-compatibility/2006" xmlns:p14="http://schemas.microsoft.com/office/powerpoint/2010/main">
+        <mc:Choice Requires="p14">
           <p:contentPart p14:bwMode="auto" r:id="rId6">
             <p14:nvContentPartPr>
               <p14:cNvPr id="5" name="Ink 4">
@@ -8236,7 +8236,7 @@
             </p14:xfrm>
           </p:contentPart>
         </mc:Choice>
-        <mc:Fallback>
+        <mc:Fallback xmlns="">
           <p:pic>
             <p:nvPicPr>
               <p:cNvPr id="5" name="Ink 4">
@@ -8267,8 +8267,8 @@
           </p:pic>
         </mc:Fallback>
       </mc:AlternateContent>
-      <mc:AlternateContent xmlns:mc="http://schemas.openxmlformats.org/markup-compatibility/2006">
-        <mc:Choice xmlns:p14="http://schemas.microsoft.com/office/powerpoint/2010/main" Requires="p14">
+      <mc:AlternateContent xmlns:mc="http://schemas.openxmlformats.org/markup-compatibility/2006" xmlns:p14="http://schemas.microsoft.com/office/powerpoint/2010/main">
+        <mc:Choice Requires="p14">
           <p:contentPart p14:bwMode="auto" r:id="rId8">
             <p14:nvContentPartPr>
               <p14:cNvPr id="6" name="Ink 5">
@@ -8287,7 +8287,7 @@
             </p14:xfrm>
           </p:contentPart>
         </mc:Choice>
-        <mc:Fallback>
+        <mc:Fallback xmlns="">
           <p:pic>
             <p:nvPicPr>
               <p:cNvPr id="6" name="Ink 5">
@@ -8318,8 +8318,8 @@
           </p:pic>
         </mc:Fallback>
       </mc:AlternateContent>
-      <mc:AlternateContent xmlns:mc="http://schemas.openxmlformats.org/markup-compatibility/2006">
-        <mc:Choice xmlns:p14="http://schemas.microsoft.com/office/powerpoint/2010/main" Requires="p14">
+      <mc:AlternateContent xmlns:mc="http://schemas.openxmlformats.org/markup-compatibility/2006" xmlns:p14="http://schemas.microsoft.com/office/powerpoint/2010/main">
+        <mc:Choice Requires="p14">
           <p:contentPart p14:bwMode="auto" r:id="rId10">
             <p14:nvContentPartPr>
               <p14:cNvPr id="7" name="Ink 6">
@@ -8338,7 +8338,7 @@
             </p14:xfrm>
           </p:contentPart>
         </mc:Choice>
-        <mc:Fallback>
+        <mc:Fallback xmlns="">
           <p:pic>
             <p:nvPicPr>
               <p:cNvPr id="7" name="Ink 6">
@@ -8945,7 +8945,7 @@
         </p:spPr>
         <p:txBody>
           <a:bodyPr spcFirstLastPara="1" wrap="square" lIns="91425" tIns="91425" rIns="91425" bIns="91425" anchor="t" anchorCtr="0">
-            <a:normAutofit fontScale="77500" lnSpcReduction="20000"/>
+            <a:normAutofit fontScale="62500" lnSpcReduction="20000"/>
           </a:bodyPr>
           <a:lstStyle/>
           <a:p>
@@ -8968,9 +8968,13 @@
             </a:r>
             <a:r>
               <a:rPr lang="en" dirty="0"/>
-              <a:t> model’s policy appears to be very consistent, as there’s a clear grouping between 200 and 300 for duration. Additionally, the reward seemst o be clustered around the 6k-7k range, but with less clear of a correlation, indicating that there might be still a little bit of randomless that leaks into the model’s landing behavior. </a:t>
+              <a:t> model’s policy appears to be very consistent, as there’s a clear grouping between 200 and 300 for duration. Additionally, the reward seems to be clustered around the 200-300 scale, with a decently normal distribution as well, which is the targeted accuracy that we need. The outliers in the 700 range and the values below 200 indicate that there’s still a little bit of randomness at play; sometimes the model will work really well and sometimes the model will work far less well depending on the starting conditions and if the model gets stuck in a certain part of </a:t>
             </a:r>
-            <a:endParaRPr dirty="0"/>
+            <a:r>
+              <a:rPr lang="en"/>
+              <a:t>the gradient. </a:t>
+            </a:r>
+            <a:endParaRPr lang="en" dirty="0"/>
           </a:p>
         </p:txBody>
       </p:sp>
@@ -8982,7 +8986,7 @@
         </p:nvSpPr>
         <p:spPr>
           <a:xfrm>
-            <a:off x="2635936" y="1277225"/>
+            <a:off x="2635937" y="1334080"/>
             <a:ext cx="6196363" cy="3725100"/>
           </a:xfrm>
           <a:prstGeom prst="rect">
@@ -9027,10 +9031,10 @@
       </p:sp>
       <p:pic>
         <p:nvPicPr>
-          <p:cNvPr id="3" name="Picture 2">
+          <p:cNvPr id="7" name="Picture 6" descr="A graph with a bar&#10;&#10;AI-generated content may be incorrect.">
             <a:extLst>
               <a:ext uri="{FF2B5EF4-FFF2-40B4-BE49-F238E27FC236}">
-                <a16:creationId xmlns:a16="http://schemas.microsoft.com/office/drawing/2014/main" id="{3EE1BC8E-0830-29C3-7B1D-0604000F013D}"/>
+                <a16:creationId xmlns:a16="http://schemas.microsoft.com/office/drawing/2014/main" id="{E3694A87-1932-4235-3943-0C1FE7457677}"/>
               </a:ext>
             </a:extLst>
           </p:cNvPr>
@@ -9047,8 +9051,8 @@
         </p:blipFill>
         <p:spPr>
           <a:xfrm>
-            <a:off x="2635937" y="1319212"/>
-            <a:ext cx="3253806" cy="2109817"/>
+            <a:off x="2695162" y="1377125"/>
+            <a:ext cx="6077909" cy="1881058"/>
           </a:xfrm>
           <a:prstGeom prst="rect">
             <a:avLst/>
@@ -9057,10 +9061,10 @@
       </p:pic>
       <p:pic>
         <p:nvPicPr>
-          <p:cNvPr id="5" name="Picture 4" descr="A graph showing a chart&#10;&#10;AI-generated content may be incorrect.">
+          <p:cNvPr id="9" name="Picture 8" descr="A graph with a blue and purple graph&#10;&#10;AI-generated content may be incorrect.">
             <a:extLst>
               <a:ext uri="{FF2B5EF4-FFF2-40B4-BE49-F238E27FC236}">
-                <a16:creationId xmlns:a16="http://schemas.microsoft.com/office/drawing/2014/main" id="{88B63945-A1F1-FE69-AC7E-386A8D0809C8}"/>
+                <a16:creationId xmlns:a16="http://schemas.microsoft.com/office/drawing/2014/main" id="{B73ACDA0-CE09-D053-83D1-E158771F2F28}"/>
               </a:ext>
             </a:extLst>
           </p:cNvPr>
@@ -9077,8 +9081,8 @@
         </p:blipFill>
         <p:spPr>
           <a:xfrm>
-            <a:off x="5943587" y="2848924"/>
-            <a:ext cx="2850515" cy="2107775"/>
+            <a:off x="2893457" y="3279523"/>
+            <a:ext cx="5681317" cy="1758317"/>
           </a:xfrm>
           <a:prstGeom prst="rect">
             <a:avLst/>

</xml_diff>